<commit_message>
feat(entrega): guion de orador generado del propio deck, PDF y README
- `docs/entrega/guion-orador.md` sale de las notas de las 45 láminas durante
  el build: no puede desincronizarse con lo que se proyecta, y se lee en un
  móvil o en una segunda pantalla mejor que las notas del .pptx.
- `docs/entrega/presentacion.pdf` para enviar la entrega sin depender de que
  el receptor abra PowerPoint.
- `docs/entrega/deck/README.md` explica cómo regenerar, qué hay en cada
  módulo y las reglas de diseño que hay que respetar al tocarlo.

El reparto de tiempo queda igual en la agenda, en el guion de demo y en el
guion de orador: 4 · 4 · 10 · 14 · 5 · 8.
</commit_message>
<xml_diff>
--- a/docs/entrega/presentacion.pptx
+++ b/docs/entrega/presentacion.pptx
@@ -17102,7 +17102,7 @@
                 <a:ea typeface="Arial" pitchFamily="34" charset="-122"/>
                 <a:cs typeface="Arial" pitchFamily="34" charset="-120"/>
               </a:rPr>
-              <a:t>Cuarenta y cinco minutos: veinte de diseño, quince de demo en vivo, diez de preguntas.</a:t>
+              <a:t>Cuarenta y cinco minutos, y casi un tercio de ellos con el sistema delante.</a:t>
             </a:r>
             <a:endParaRPr lang="en-US" sz="2600" dirty="0"/>
           </a:p>
@@ -17367,7 +17367,7 @@
                 <a:ea typeface="Courier New" pitchFamily="34" charset="-122"/>
                 <a:cs typeface="Courier New" pitchFamily="34" charset="-120"/>
               </a:rPr>
-              <a:t>3 min</a:t>
+              <a:t>4 min</a:t>
             </a:r>
             <a:endParaRPr lang="en-US" sz="1050" dirty="0"/>
           </a:p>
@@ -17791,7 +17791,7 @@
                 <a:ea typeface="Courier New" pitchFamily="34" charset="-122"/>
                 <a:cs typeface="Courier New" pitchFamily="34" charset="-120"/>
               </a:rPr>
-              <a:t>11 min</a:t>
+              <a:t>10 min</a:t>
             </a:r>
             <a:endParaRPr lang="en-US" sz="1050" dirty="0"/>
           </a:p>

</xml_diff>